<commit_message>
fix: correct diamond shape in README and PPT (was hourglass, now narrow-wide-narrow)
Co-authored-by: Copilot <223556219+Copilot@users.noreply.github.com>
</commit_message>
<xml_diff>
--- a/PRM-Design.pptx
+++ b/PRM-Design.pptx
@@ -15564,7 +15564,7 @@
                   <a:srgbClr val="FFFFFF"/>
                 </a:solidFill>
               </a:rPr>
-              <a:t>   \        /</a:t>
+              <a:t>  │ ⊕ ⊕ ⊕  │</a:t>
             </a:r>
           </a:p>
         </p:txBody>
@@ -15598,7 +15598,7 @@
                   <a:srgbClr val="FFA500"/>
                 </a:solidFill>
               </a:rPr>
-              <a:t>    \  ⊕⊕  /   WIDENING</a:t>
+              <a:t>   /  ⊕⊕⊕  \   WIDENING</a:t>
             </a:r>
           </a:p>
         </p:txBody>
@@ -15632,7 +15632,7 @@
                   <a:srgbClr val="FFFFFF"/>
                 </a:solidFill>
               </a:rPr>
-              <a:t>     \⊕⊕⊕/    (divergent</a:t>
+              <a:t>  /  ⊕⊕⊕⊕   \  (divergent</a:t>
             </a:r>
           </a:p>
         </p:txBody>
@@ -15666,7 +15666,7 @@
                   <a:srgbClr val="FFFFFF"/>
                 </a:solidFill>
               </a:rPr>
-              <a:t>      ⊕⊕⊕      thinking)</a:t>
+              <a:t> /  ⊕⊕⊕⊕⊕   \ thinking)</a:t>
             </a:r>
           </a:p>
         </p:txBody>
@@ -15697,10 +15697,10 @@
             <a:r>
               <a:rPr sz="1200" b="0" i="0">
                 <a:solidFill>
-                  <a:srgbClr val="FFFFFF"/>
-                </a:solidFill>
-              </a:rPr>
-              <a:t>     /⊕⊕⊕\</a:t>
+                  <a:srgbClr val="FFA500"/>
+                </a:solidFill>
+              </a:rPr>
+              <a:t>  \  ⊕⊕⊕⊕  /   NARROWING</a:t>
             </a:r>
           </a:p>
         </p:txBody>
@@ -15731,10 +15731,10 @@
             <a:r>
               <a:rPr sz="1200" b="0" i="0">
                 <a:solidFill>
-                  <a:srgbClr val="FFA500"/>
-                </a:solidFill>
-              </a:rPr>
-              <a:t>    /  ⊕⊕  \   NARROWING</a:t>
+                  <a:srgbClr val="FFFFFF"/>
+                </a:solidFill>
+              </a:rPr>
+              <a:t>   \  ⊕⊕⊕  /   (summarizing)</a:t>
             </a:r>
           </a:p>
         </p:txBody>
@@ -15768,7 +15768,7 @@
                   <a:srgbClr val="FFFFFF"/>
                 </a:solidFill>
               </a:rPr>
-              <a:t>   /        \  (summarizing)</a:t>
+              <a:t>  │ ⊕ ⊕ ⊕  │</a:t>
             </a:r>
           </a:p>
         </p:txBody>

</xml_diff>